<commit_message>
Live-first session prompts, Gemini Notebook rename, self-contained site
- Session prompt accordions now lead with the tradie receipt-scanner
  version (paste as-is to follow along), template below for their own idea
- NotebookLM renamed to Gemini Notebook (July 2026) across site, builder,
  deck, and run-of-show; deck names Msty and Gemini Notebook on slides 5/12
- 'The idea behind it' is now an in-page overlay (Conversation, not
  Delegation: the contrast + the four-step loop) instead of leaving the site
- Removed 'the big picture' links — self-promotional, broke the flow
</commit_message>
<xml_diff>
--- a/slides/deck.pptx
+++ b/slides/deck.pptx
@@ -3666,6 +3666,29 @@
             </a:r>
           </a:p>
           <a:p>
+            <a:pPr lvl="0"/>
+            <a:r>
+              <a:rPr/>
+              <a:t>The tools: today’s free chat, </a:t>
+            </a:r>
+            <a:r>
+              <a:rPr b="1"/>
+              <a:t>Gemini Notebook</a:t>
+            </a:r>
+            <a:r>
+              <a:rPr/>
+              <a:t> for your documents, </a:t>
+            </a:r>
+            <a:r>
+              <a:rPr b="1"/>
+              <a:t>Msty</a:t>
+            </a:r>
+            <a:r>
+              <a:rPr/>
+              <a:t> for private local AI — all linked on the site.</a:t>
+            </a:r>
+          </a:p>
+          <a:p>
             <a:pPr lvl="0" indent="0" marL="0">
               <a:spcBef>
                 <a:spcPts val="3000"/>
@@ -4184,7 +4207,7 @@
             </a:pPr>
             <a:r>
               <a:rPr i="1"/>
-              <a:t>Run each on YOUR idea, in parallel with the volunteer’s. Sensitive idea? Work the tradie example today — run yours tonight on a local model.</a:t>
+              <a:t>Run each on YOUR idea, in parallel with the volunteer’s. Sensitive idea? Work the tradie example today — run yours tonight in Msty (one install, nothing leaves your laptop).</a:t>
             </a:r>
           </a:p>
         </p:txBody>

</xml_diff>

<commit_message>
Walk-the-talk slide, Scale/Pivot/Kill explainer, beginner fixes on slide 5
- New slide 3 'Walk the talk': ~30 tools, AI taught at undergrad/postgrad/
  exec ed, and the deck+site+poll themselves built in conversation with AI
- Companion: Scale/Pivot/Kill explainer after the strategies; OpenClaw and
  Codex cards beside the Agents framing card
- Slide 5: chat URLs on screen (gemini.google.com / chatgpt.com / claude.ai)
  and explicit 'or just watch — both work' permission
- Facilitator: cut plan (drop move 3 pass 2 if behind at 36); script
  references the walk-the-talk slide
</commit_message>
<xml_diff>
--- a/slides/deck.pptx
+++ b/slides/deck.pptx
@@ -17,6 +17,7 @@
     <p:sldId id="265" r:id="rId11"/>
     <p:sldId id="266" r:id="rId12"/>
     <p:sldId id="267" r:id="rId13"/>
+    <p:sldId id="268" r:id="rId14"/>
   </p:sldIdLst>
   <p:sldSz cx="9144000" cy="5143500" type="screen16x9"/>
   <p:notesSz cx="6858000" cy="9144000"/>
@@ -3398,7 +3399,7 @@
             </a:pPr>
             <a:r>
               <a:rPr/>
-              <a:t>The trust tool</a:t>
+              <a:t>Push back: three ways</a:t>
             </a:r>
           </a:p>
         </p:txBody>
@@ -3418,43 +3419,55 @@
           <a:bodyPr/>
           <a:lstStyle/>
           <a:p>
+            <a:pPr lvl="0" indent="-342900" marL="342900">
+              <a:buAutoNum type="arabicPeriod"/>
+            </a:pPr>
+            <a:r>
+              <a:rPr b="1"/>
+              <a:t>Devil’s advocate</a:t>
+            </a:r>
+            <a:r>
+              <a:rPr/>
+              <a:t> — make it attack your idea; you decide what survives. </a:t>
+            </a:r>
+            <a:r>
+              <a:rPr i="1"/>
+              <a:t>(You just did this in move 2.)</a:t>
+            </a:r>
+          </a:p>
+          <a:p>
+            <a:pPr lvl="0" indent="-342900" marL="342900">
+              <a:buAutoNum type="arabicPeriod"/>
+            </a:pPr>
+            <a:r>
+              <a:rPr b="1"/>
+              <a:t>Board of directors</a:t>
+            </a:r>
+            <a:r>
+              <a:rPr/>
+              <a:t> — a room of voices (CFO, sceptical customer, growth marketer), not one answer. You weigh them.</a:t>
+            </a:r>
+          </a:p>
+          <a:p>
+            <a:pPr lvl="0" indent="-342900" marL="342900">
+              <a:buAutoNum type="arabicPeriod"/>
+            </a:pPr>
+            <a:r>
+              <a:rPr b="1"/>
+              <a:t>VET</a:t>
+            </a:r>
+            <a:r>
+              <a:rPr/>
+              <a:t> — Verify the source · Explain it back · Test the edges. For any claim you can’t check.</a:t>
+            </a:r>
+          </a:p>
+          <a:p>
             <a:pPr lvl="0" indent="0" marL="0">
               <a:buNone/>
             </a:pPr>
             <a:r>
-              <a:rPr b="1"/>
-              <a:t>Average / Precise × Small / Large.</a:t>
-            </a:r>
-          </a:p>
-          <a:p>
-            <a:pPr lvl="0"/>
-            <a:r>
-              <a:rPr b="1"/>
-              <a:t>Lean in:</a:t>
-            </a:r>
-            <a:r>
-              <a:rPr/>
-              <a:t> competitor scans, brainstorming, first drafts.</a:t>
-            </a:r>
-          </a:p>
-          <a:p>
-            <a:pPr lvl="0"/>
-            <a:r>
-              <a:rPr b="1"/>
-              <a:t>Human owns it:</a:t>
-            </a:r>
-            <a:r>
-              <a:rPr/>
-              <a:t> the go/no-go, the customer, the positioning call, any number in a pitch.</a:t>
-            </a:r>
-          </a:p>
-          <a:p>
-            <a:pPr lvl="0" indent="0" marL="0">
-              <a:buNone/>
-            </a:pPr>
-            <a:r>
               <a:rPr i="1"/>
-              <a:t>Where it hurts to be wrong, you stay in charge — and when the grid says verify, VET it.</a:t>
+              <a:t>Prompts for all three are on the companion site.</a:t>
             </a:r>
           </a:p>
         </p:txBody>
@@ -3501,7 +3514,7 @@
             </a:pPr>
             <a:r>
               <a:rPr/>
-              <a:t>The method, in three sentences</a:t>
+              <a:t>The trust tool</a:t>
             </a:r>
           </a:p>
         </p:txBody>
@@ -3521,47 +3534,43 @@
           <a:bodyPr/>
           <a:lstStyle/>
           <a:p>
-            <a:pPr lvl="0" indent="-342900" marL="342900">
-              <a:buAutoNum type="arabicPeriod"/>
+            <a:pPr lvl="0" indent="0" marL="0">
+              <a:buNone/>
             </a:pPr>
             <a:r>
               <a:rPr b="1"/>
-              <a:t>Add context</a:t>
-            </a:r>
-            <a:r>
-              <a:rPr/>
-              <a:t> — the specifics only you hold.</a:t>
-            </a:r>
-          </a:p>
-          <a:p>
-            <a:pPr lvl="0" indent="-342900" marL="342900">
-              <a:buAutoNum type="arabicPeriod"/>
-            </a:pPr>
+              <a:t>Average / Precise × Small / Large.</a:t>
+            </a:r>
+          </a:p>
+          <a:p>
+            <a:pPr lvl="0"/>
             <a:r>
               <a:rPr b="1"/>
-              <a:t>Prompt past the flattery</a:t>
-            </a:r>
-            <a:r>
-              <a:rPr/>
-              <a:t> — ask “why does this fail?”, not “what do you think?”</a:t>
-            </a:r>
-          </a:p>
-          <a:p>
-            <a:pPr lvl="0" indent="-342900" marL="342900">
-              <a:buAutoNum type="arabicPeriod"/>
-            </a:pPr>
+              <a:t>Lean in:</a:t>
+            </a:r>
+            <a:r>
+              <a:rPr/>
+              <a:t> competitor scans, brainstorming, first drafts.</a:t>
+            </a:r>
+          </a:p>
+          <a:p>
+            <a:pPr lvl="0"/>
             <a:r>
               <a:rPr b="1"/>
-              <a:t>Stay sceptical where you know least.</a:t>
-            </a:r>
-          </a:p>
-          <a:p>
-            <a:pPr lvl="0" indent="0" marL="1270000">
-              <a:buNone/>
-            </a:pPr>
-            <a:r>
-              <a:rPr sz="2000"/>
-              <a:t>AI as a thinking partner, not a stand-in.</a:t>
+              <a:t>Human owns it:</a:t>
+            </a:r>
+            <a:r>
+              <a:rPr/>
+              <a:t> the go/no-go, the customer, the positioning call, any number in a pitch.</a:t>
+            </a:r>
+          </a:p>
+          <a:p>
+            <a:pPr lvl="0" indent="0" marL="0">
+              <a:buNone/>
+            </a:pPr>
+            <a:r>
+              <a:rPr i="1"/>
+              <a:t>Where it hurts to be wrong, you stay in charge — and when the grid says verify, VET it.</a:t>
             </a:r>
           </a:p>
         </p:txBody>
@@ -3572,6 +3581,113 @@
 </file>
 
 <file path=ppt/slides/slide12.xml><?xml version="1.0" encoding="utf-8"?>
+<p:sld xmlns:a="http://schemas.openxmlformats.org/drawingml/2006/main" xmlns:r="http://schemas.openxmlformats.org/officeDocument/2006/relationships" xmlns:p="http://schemas.openxmlformats.org/presentationml/2006/main">
+  <p:cSld>
+    <p:spTree>
+      <p:nvGrpSpPr>
+        <p:cNvPr id="1" name=""/>
+        <p:cNvGrpSpPr/>
+        <p:nvPr/>
+      </p:nvGrpSpPr>
+      <p:grpSpPr>
+        <a:xfrm>
+          <a:off x="0" y="0"/>
+          <a:ext cx="0" cy="0"/>
+          <a:chOff x="0" y="0"/>
+          <a:chExt cx="0" cy="0"/>
+        </a:xfrm>
+      </p:grpSpPr>
+      <p:sp>
+        <p:nvSpPr>
+          <p:cNvPr id="2" name="Title 1"/>
+          <p:cNvSpPr>
+            <a:spLocks noGrp="1"/>
+          </p:cNvSpPr>
+          <p:nvPr>
+            <p:ph type="title"/>
+          </p:nvPr>
+        </p:nvSpPr>
+        <p:spPr/>
+        <p:txBody>
+          <a:bodyPr/>
+          <a:lstStyle/>
+          <a:p>
+            <a:pPr lvl="0" indent="0" marL="0">
+              <a:buNone/>
+            </a:pPr>
+            <a:r>
+              <a:rPr/>
+              <a:t>The method, in three sentences</a:t>
+            </a:r>
+          </a:p>
+        </p:txBody>
+      </p:sp>
+      <p:sp>
+        <p:nvSpPr>
+          <p:cNvPr id="3" name="Content Placeholder 2"/>
+          <p:cNvSpPr>
+            <a:spLocks noGrp="1"/>
+          </p:cNvSpPr>
+          <p:nvPr>
+            <p:ph idx="1"/>
+          </p:nvPr>
+        </p:nvSpPr>
+        <p:spPr/>
+        <p:txBody>
+          <a:bodyPr/>
+          <a:lstStyle/>
+          <a:p>
+            <a:pPr lvl="0" indent="-342900" marL="342900">
+              <a:buAutoNum type="arabicPeriod"/>
+            </a:pPr>
+            <a:r>
+              <a:rPr b="1"/>
+              <a:t>Add context</a:t>
+            </a:r>
+            <a:r>
+              <a:rPr/>
+              <a:t> — the specifics only you hold.</a:t>
+            </a:r>
+          </a:p>
+          <a:p>
+            <a:pPr lvl="0" indent="-342900" marL="342900">
+              <a:buAutoNum type="arabicPeriod"/>
+            </a:pPr>
+            <a:r>
+              <a:rPr b="1"/>
+              <a:t>Prompt past the flattery</a:t>
+            </a:r>
+            <a:r>
+              <a:rPr/>
+              <a:t> — ask “why does this fail?”, not “what do you think?”</a:t>
+            </a:r>
+          </a:p>
+          <a:p>
+            <a:pPr lvl="0" indent="-342900" marL="342900">
+              <a:buAutoNum type="arabicPeriod"/>
+            </a:pPr>
+            <a:r>
+              <a:rPr b="1"/>
+              <a:t>Stay sceptical where you know least.</a:t>
+            </a:r>
+          </a:p>
+          <a:p>
+            <a:pPr lvl="0" indent="0" marL="1270000">
+              <a:buNone/>
+            </a:pPr>
+            <a:r>
+              <a:rPr sz="2000"/>
+              <a:t>AI as a thinking partner, not a stand-in.</a:t>
+            </a:r>
+          </a:p>
+        </p:txBody>
+      </p:sp>
+    </p:spTree>
+  </p:cSld>
+</p:sld>
+</file>
+
+<file path=ppt/slides/slide13.xml><?xml version="1.0" encoding="utf-8"?>
 <p:sld xmlns:a="http://schemas.openxmlformats.org/drawingml/2006/main" xmlns:r="http://schemas.openxmlformats.org/officeDocument/2006/relationships" xmlns:p="http://schemas.openxmlformats.org/presentationml/2006/main">
   <p:cSld>
     <p:spTree>
@@ -3912,7 +4028,7 @@
             </a:pPr>
             <a:r>
               <a:rPr/>
-              <a:t>Trap 1: Sycophancy</a:t>
+              <a:t>Walk the talk</a:t>
             </a:r>
           </a:p>
         </p:txBody>
@@ -3932,55 +4048,57 @@
           <a:bodyPr/>
           <a:lstStyle/>
           <a:p>
+            <a:pPr lvl="0"/>
+            <a:r>
+              <a:rPr/>
+              <a:t>One academic, in conversation with AI: </a:t>
+            </a:r>
+            <a:r>
+              <a:rPr b="1"/>
+              <a:t>~30 tools</a:t>
+            </a:r>
+            <a:r>
+              <a:rPr/>
+              <a:t> designed, built, and shipped solo — bigpicture.borck.dev</a:t>
+            </a:r>
+          </a:p>
+          <a:p>
+            <a:pPr lvl="0"/>
+            <a:r>
+              <a:rPr/>
+              <a:t>AI taught at </a:t>
+            </a:r>
+            <a:r>
+              <a:rPr b="1"/>
+              <a:t>undergraduate, postgraduate, and executive</a:t>
+            </a:r>
+            <a:r>
+              <a:rPr/>
+              <a:t> levels (Curtin) — the books are free at books.borck.education</a:t>
+            </a:r>
+          </a:p>
+          <a:p>
+            <a:pPr lvl="0"/>
+            <a:r>
+              <a:rPr/>
+              <a:t>This deck, the companion site, and the poll you just answered were </a:t>
+            </a:r>
+            <a:r>
+              <a:rPr b="1"/>
+              <a:t>built in conversation with AI</a:t>
+            </a:r>
+            <a:r>
+              <a:rPr/>
+              <a:t>. That is the point.</a:t>
+            </a:r>
+          </a:p>
+          <a:p>
             <a:pPr lvl="0" indent="0" marL="0">
               <a:buNone/>
             </a:pPr>
             <a:r>
-              <a:rPr/>
-              <a:t>The model tells you what you want to hear.</a:t>
-            </a:r>
-          </a:p>
-          <a:p>
-            <a:pPr lvl="0" indent="0" marL="0">
-              <a:buNone/>
-            </a:pPr>
-            <a:r>
-              <a:rPr/>
-              <a:t>Ask </a:t>
-            </a:r>
-            <a:r>
               <a:rPr i="1"/>
-              <a:t>“what do you think?”</a:t>
-            </a:r>
-            <a:r>
-              <a:rPr/>
-              <a:t> → praise first, gentle critique second.</a:t>
-            </a:r>
-          </a:p>
-          <a:p>
-            <a:pPr lvl="0" indent="0" marL="0">
-              <a:buNone/>
-            </a:pPr>
-            <a:r>
-              <a:rPr/>
-              <a:t>It’s managing your feelings, not assessing your work.</a:t>
-            </a:r>
-          </a:p>
-          <a:p>
-            <a:pPr lvl="0" indent="0" marL="0">
-              <a:buNone/>
-            </a:pPr>
-            <a:r>
-              <a:rPr b="1"/>
-              <a:t>Defence:</a:t>
-            </a:r>
-            <a:r>
-              <a:rPr/>
-              <a:t> prompt past it. </a:t>
-            </a:r>
-            <a:r>
-              <a:rPr i="1"/>
-              <a:t>(We do this in move 2.)</a:t>
+              <a:t>Thirty seconds, dry understatement, move on.</a:t>
             </a:r>
           </a:p>
         </p:txBody>
@@ -4027,7 +4145,7 @@
             </a:pPr>
             <a:r>
               <a:rPr/>
-              <a:t>Trap 2: Gell-Mann Amnesia</a:t>
+              <a:t>Trap 1: Sycophancy</a:t>
             </a:r>
           </a:p>
         </p:txBody>
@@ -4052,7 +4170,7 @@
             </a:pPr>
             <a:r>
               <a:rPr/>
-              <a:t>You catch its errors in your own domain.</a:t>
+              <a:t>The model tells you what you want to hear.</a:t>
             </a:r>
           </a:p>
           <a:p>
@@ -4061,7 +4179,15 @@
             </a:pPr>
             <a:r>
               <a:rPr/>
-              <a:t>You trust it on the market, the regs, the numbers — the bits you can’t check.</a:t>
+              <a:t>Ask </a:t>
+            </a:r>
+            <a:r>
+              <a:rPr i="1"/>
+              <a:t>“what do you think?”</a:t>
+            </a:r>
+            <a:r>
+              <a:rPr/>
+              <a:t> → praise first, gentle critique second.</a:t>
             </a:r>
           </a:p>
           <a:p>
@@ -4070,11 +4196,24 @@
             </a:pPr>
             <a:r>
               <a:rPr/>
-              <a:t>Smooth prose feels authoritative. </a:t>
-            </a:r>
+              <a:t>It’s managing your feelings, not assessing your work.</a:t>
+            </a:r>
+          </a:p>
+          <a:p>
+            <a:pPr lvl="0" indent="0" marL="0">
+              <a:buNone/>
+            </a:pPr>
             <a:r>
               <a:rPr b="1"/>
-              <a:t>Smoothness ≠ accuracy.</a:t>
+              <a:t>Defence:</a:t>
+            </a:r>
+            <a:r>
+              <a:rPr/>
+              <a:t> prompt past it. </a:t>
+            </a:r>
+            <a:r>
+              <a:rPr i="1"/>
+              <a:t>(We do this in move 2.)</a:t>
             </a:r>
           </a:p>
         </p:txBody>
@@ -4111,6 +4250,100 @@
             <p:ph type="title"/>
           </p:nvPr>
         </p:nvSpPr>
+        <p:spPr/>
+        <p:txBody>
+          <a:bodyPr/>
+          <a:lstStyle/>
+          <a:p>
+            <a:pPr lvl="0" indent="0" marL="0">
+              <a:buNone/>
+            </a:pPr>
+            <a:r>
+              <a:rPr/>
+              <a:t>Trap 2: Gell-Mann Amnesia</a:t>
+            </a:r>
+          </a:p>
+        </p:txBody>
+      </p:sp>
+      <p:sp>
+        <p:nvSpPr>
+          <p:cNvPr id="3" name="Content Placeholder 2"/>
+          <p:cNvSpPr>
+            <a:spLocks noGrp="1"/>
+          </p:cNvSpPr>
+          <p:nvPr>
+            <p:ph idx="1"/>
+          </p:nvPr>
+        </p:nvSpPr>
+        <p:spPr/>
+        <p:txBody>
+          <a:bodyPr/>
+          <a:lstStyle/>
+          <a:p>
+            <a:pPr lvl="0" indent="0" marL="0">
+              <a:buNone/>
+            </a:pPr>
+            <a:r>
+              <a:rPr/>
+              <a:t>You catch its errors in your own domain.</a:t>
+            </a:r>
+          </a:p>
+          <a:p>
+            <a:pPr lvl="0" indent="0" marL="0">
+              <a:buNone/>
+            </a:pPr>
+            <a:r>
+              <a:rPr/>
+              <a:t>You trust it on the market, the regs, the numbers — the bits you can’t check.</a:t>
+            </a:r>
+          </a:p>
+          <a:p>
+            <a:pPr lvl="0" indent="0" marL="0">
+              <a:buNone/>
+            </a:pPr>
+            <a:r>
+              <a:rPr/>
+              <a:t>Smooth prose feels authoritative. </a:t>
+            </a:r>
+            <a:r>
+              <a:rPr b="1"/>
+              <a:t>Smoothness ≠ accuracy.</a:t>
+            </a:r>
+          </a:p>
+        </p:txBody>
+      </p:sp>
+    </p:spTree>
+  </p:cSld>
+</p:sld>
+</file>
+
+<file path=ppt/slides/slide6.xml><?xml version="1.0" encoding="utf-8"?>
+<p:sld xmlns:a="http://schemas.openxmlformats.org/drawingml/2006/main" xmlns:r="http://schemas.openxmlformats.org/officeDocument/2006/relationships" xmlns:p="http://schemas.openxmlformats.org/presentationml/2006/main">
+  <p:cSld>
+    <p:spTree>
+      <p:nvGrpSpPr>
+        <p:cNvPr id="1" name=""/>
+        <p:cNvGrpSpPr/>
+        <p:nvPr/>
+      </p:nvGrpSpPr>
+      <p:grpSpPr>
+        <a:xfrm>
+          <a:off x="0" y="0"/>
+          <a:ext cx="0" cy="0"/>
+          <a:chOff x="0" y="0"/>
+          <a:chExt cx="0" cy="0"/>
+        </a:xfrm>
+      </p:grpSpPr>
+      <p:sp>
+        <p:nvSpPr>
+          <p:cNvPr id="2" name="Title 1"/>
+          <p:cNvSpPr>
+            <a:spLocks noGrp="1"/>
+          </p:cNvSpPr>
+          <p:nvPr>
+            <p:ph type="title"/>
+          </p:nvPr>
+        </p:nvSpPr>
         <p:spPr>
           <a:xfrm>
             <a:off x="457201" y="204787"/>
@@ -4207,7 +4440,25 @@
             </a:pPr>
             <a:r>
               <a:rPr i="1"/>
-              <a:t>Run each on YOUR idea, in parallel with the volunteer’s. Sensitive idea? Work the tradie example today — run yours tonight in Msty (one install, nothing leaves your laptop).</a:t>
+              <a:t>Run each on YOUR idea, in parallel with the volunteer’s — or just watch. Both work.</a:t>
+            </a:r>
+          </a:p>
+          <a:p>
+            <a:pPr lvl="0" indent="0" marL="0">
+              <a:buNone/>
+            </a:pPr>
+            <a:r>
+              <a:rPr i="1"/>
+              <a:t>Open one: gemini.google.com · chatgpt.com · claude.ai</a:t>
+            </a:r>
+          </a:p>
+          <a:p>
+            <a:pPr lvl="0" indent="0" marL="0">
+              <a:buNone/>
+            </a:pPr>
+            <a:r>
+              <a:rPr i="1"/>
+              <a:t>Sensitive idea? Work the tradie example today — run yours tonight in Msty (one install, nothing leaves your laptop).</a:t>
             </a:r>
           </a:p>
         </p:txBody>
@@ -4279,116 +4530,6 @@
 </p:sld>
 </file>
 
-<file path=ppt/slides/slide6.xml><?xml version="1.0" encoding="utf-8"?>
-<p:sld xmlns:a="http://schemas.openxmlformats.org/drawingml/2006/main" xmlns:r="http://schemas.openxmlformats.org/officeDocument/2006/relationships" xmlns:p="http://schemas.openxmlformats.org/presentationml/2006/main">
-  <p:cSld>
-    <p:spTree>
-      <p:nvGrpSpPr>
-        <p:cNvPr id="1" name=""/>
-        <p:cNvGrpSpPr/>
-        <p:nvPr/>
-      </p:nvGrpSpPr>
-      <p:grpSpPr>
-        <a:xfrm>
-          <a:off x="0" y="0"/>
-          <a:ext cx="0" cy="0"/>
-          <a:chOff x="0" y="0"/>
-          <a:chExt cx="0" cy="0"/>
-        </a:xfrm>
-      </p:grpSpPr>
-      <p:sp>
-        <p:nvSpPr>
-          <p:cNvPr id="2" name="Title 1"/>
-          <p:cNvSpPr>
-            <a:spLocks noGrp="1"/>
-          </p:cNvSpPr>
-          <p:nvPr>
-            <p:ph type="title"/>
-          </p:nvPr>
-        </p:nvSpPr>
-        <p:spPr/>
-        <p:txBody>
-          <a:bodyPr/>
-          <a:lstStyle/>
-          <a:p>
-            <a:pPr lvl="0" indent="0" marL="0">
-              <a:buNone/>
-            </a:pPr>
-            <a:r>
-              <a:rPr/>
-              <a:t>Move 1: Validate (two-pass)</a:t>
-            </a:r>
-          </a:p>
-        </p:txBody>
-      </p:sp>
-      <p:sp>
-        <p:nvSpPr>
-          <p:cNvPr id="3" name="Content Placeholder 2"/>
-          <p:cNvSpPr>
-            <a:spLocks noGrp="1"/>
-          </p:cNvSpPr>
-          <p:nvPr>
-            <p:ph idx="1"/>
-          </p:nvPr>
-        </p:nvSpPr>
-        <p:spPr/>
-        <p:txBody>
-          <a:bodyPr/>
-          <a:lstStyle/>
-          <a:p>
-            <a:pPr lvl="0" indent="0" marL="0">
-              <a:buNone/>
-            </a:pPr>
-            <a:r>
-              <a:rPr b="1"/>
-              <a:t>Pass 1 (naive):</a:t>
-            </a:r>
-            <a:r>
-              <a:rPr/>
-              <a:t> an enthusiastic, over-long love-fest. </a:t>
-            </a:r>
-            <a:r>
-              <a:rPr i="1"/>
-              <a:t>Sycophancy, live.</a:t>
-            </a:r>
-          </a:p>
-          <a:p>
-            <a:pPr lvl="0" indent="0" marL="0">
-              <a:buNone/>
-            </a:pPr>
-            <a:r>
-              <a:rPr b="1"/>
-              <a:t>Pass 2 (with edge):</a:t>
-            </a:r>
-            <a:r>
-              <a:rPr/>
-              <a:t> Role · Task · </a:t>
-            </a:r>
-            <a:r>
-              <a:rPr b="1"/>
-              <a:t>Context</a:t>
-            </a:r>
-            <a:r>
-              <a:rPr/>
-              <a:t> · Format.</a:t>
-            </a:r>
-          </a:p>
-          <a:p>
-            <a:pPr lvl="0" indent="0" marL="1270000">
-              <a:buNone/>
-            </a:pPr>
-            <a:r>
-              <a:rPr sz="2000"/>
-              <a:t>Context is where your edge enters. No model supplies it.</a:t>
-            </a:r>
-          </a:p>
-        </p:txBody>
-      </p:sp>
-    </p:spTree>
-  </p:cSld>
-</p:sld>
-</file>
-
 <file path=ppt/slides/slide7.xml><?xml version="1.0" encoding="utf-8"?>
 <p:sld xmlns:a="http://schemas.openxmlformats.org/drawingml/2006/main" xmlns:r="http://schemas.openxmlformats.org/officeDocument/2006/relationships" xmlns:p="http://schemas.openxmlformats.org/presentationml/2006/main">
   <p:cSld>
@@ -4426,7 +4567,7 @@
             </a:pPr>
             <a:r>
               <a:rPr/>
-              <a:t>Move 2: Pressure-test</a:t>
+              <a:t>Move 1: Validate (two-pass)</a:t>
             </a:r>
           </a:p>
         </p:txBody>
@@ -4446,38 +4587,50 @@
           <a:bodyPr/>
           <a:lstStyle/>
           <a:p>
+            <a:pPr lvl="0" indent="0" marL="0">
+              <a:buNone/>
+            </a:pPr>
+            <a:r>
+              <a:rPr b="1"/>
+              <a:t>Pass 1 (naive):</a:t>
+            </a:r>
+            <a:r>
+              <a:rPr/>
+              <a:t> an enthusiastic, over-long love-fest. </a:t>
+            </a:r>
+            <a:r>
+              <a:rPr i="1"/>
+              <a:t>Sycophancy, live.</a:t>
+            </a:r>
+          </a:p>
+          <a:p>
+            <a:pPr lvl="0" indent="0" marL="0">
+              <a:buNone/>
+            </a:pPr>
+            <a:r>
+              <a:rPr b="1"/>
+              <a:t>Pass 2 (with edge):</a:t>
+            </a:r>
+            <a:r>
+              <a:rPr/>
+              <a:t> Role · Task · </a:t>
+            </a:r>
+            <a:r>
+              <a:rPr b="1"/>
+              <a:t>Context</a:t>
+            </a:r>
+            <a:r>
+              <a:rPr/>
+              <a:t> · Format.</a:t>
+            </a:r>
+          </a:p>
+          <a:p>
             <a:pPr lvl="0" indent="0" marL="1270000">
               <a:buNone/>
             </a:pPr>
             <a:r>
               <a:rPr sz="2000"/>
-              <a:t>Do not flatter me. Three reasons this fails. Name the load-bearing assumption.</a:t>
-            </a:r>
-          </a:p>
-          <a:p>
-            <a:pPr lvl="0" indent="0" marL="0">
-              <a:buNone/>
-            </a:pPr>
-            <a:r>
-              <a:rPr/>
-              <a:t>Then: </a:t>
-            </a:r>
-            <a:r>
-              <a:rPr b="1"/>
-              <a:t>Scale / Pivot / Kill</a:t>
-            </a:r>
-            <a:r>
-              <a:rPr/>
-              <a:t> — and the cheapest experiment that moves it up a notch.</a:t>
-            </a:r>
-          </a:p>
-          <a:p>
-            <a:pPr lvl="0" indent="0" marL="0">
-              <a:buNone/>
-            </a:pPr>
-            <a:r>
-              <a:rPr i="1"/>
-              <a:t>Killing is a good outcome.</a:t>
+              <a:t>Context is where your edge enters. No model supplies it.</a:t>
             </a:r>
           </a:p>
         </p:txBody>
@@ -4524,7 +4677,7 @@
             </a:pPr>
             <a:r>
               <a:rPr/>
-              <a:t>Move 3: Sharpen the pitch</a:t>
+              <a:t>Move 2: Pressure-test</a:t>
             </a:r>
           </a:p>
         </p:txBody>
@@ -4544,16 +4697,29 @@
           <a:bodyPr/>
           <a:lstStyle/>
           <a:p>
+            <a:pPr lvl="0" indent="0" marL="1270000">
+              <a:buNone/>
+            </a:pPr>
+            <a:r>
+              <a:rPr sz="2000"/>
+              <a:t>Do not flatter me. Three reasons this fails. Name the load-bearing assumption.</a:t>
+            </a:r>
+          </a:p>
+          <a:p>
             <a:pPr lvl="0" indent="0" marL="0">
               <a:buNone/>
             </a:pPr>
             <a:r>
+              <a:rPr/>
+              <a:t>Then: </a:t>
+            </a:r>
+            <a:r>
               <a:rPr b="1"/>
-              <a:t>Pass 1:</a:t>
-            </a:r>
-            <a:r>
-              <a:rPr/>
-              <a:t> generic 60-word pitch. Forgettable.</a:t>
+              <a:t>Scale / Pivot / Kill</a:t>
+            </a:r>
+            <a:r>
+              <a:rPr/>
+              <a:t> — and the cheapest experiment that moves it up a notch.</a:t>
             </a:r>
           </a:p>
           <a:p>
@@ -4561,20 +4727,8 @@
               <a:buNone/>
             </a:pPr>
             <a:r>
-              <a:rPr b="1"/>
-              <a:t>Pass 2:</a:t>
-            </a:r>
-            <a:r>
-              <a:rPr/>
-              <a:t> in </a:t>
-            </a:r>
-            <a:r>
               <a:rPr i="1"/>
-              <a:t>your</a:t>
-            </a:r>
-            <a:r>
-              <a:rPr/>
-              <a:t> voice, leading with the one thing only you would say.</a:t>
+              <a:t>Killing is a good outcome.</a:t>
             </a:r>
           </a:p>
         </p:txBody>
@@ -4621,7 +4775,7 @@
             </a:pPr>
             <a:r>
               <a:rPr/>
-              <a:t>Push back: three ways</a:t>
+              <a:t>Move 3: Sharpen the pitch</a:t>
             </a:r>
           </a:p>
         </p:txBody>
@@ -4641,55 +4795,37 @@
           <a:bodyPr/>
           <a:lstStyle/>
           <a:p>
-            <a:pPr lvl="0" indent="-342900" marL="342900">
-              <a:buAutoNum type="arabicPeriod"/>
+            <a:pPr lvl="0" indent="0" marL="0">
+              <a:buNone/>
             </a:pPr>
             <a:r>
               <a:rPr b="1"/>
-              <a:t>Devil’s advocate</a:t>
-            </a:r>
-            <a:r>
-              <a:rPr/>
-              <a:t> — make it attack your idea; you decide what survives. </a:t>
+              <a:t>Pass 1:</a:t>
+            </a:r>
+            <a:r>
+              <a:rPr/>
+              <a:t> generic 60-word pitch. Forgettable.</a:t>
+            </a:r>
+          </a:p>
+          <a:p>
+            <a:pPr lvl="0" indent="0" marL="0">
+              <a:buNone/>
+            </a:pPr>
+            <a:r>
+              <a:rPr b="1"/>
+              <a:t>Pass 2:</a:t>
+            </a:r>
+            <a:r>
+              <a:rPr/>
+              <a:t> in </a:t>
             </a:r>
             <a:r>
               <a:rPr i="1"/>
-              <a:t>(You just did this in move 2.)</a:t>
-            </a:r>
-          </a:p>
-          <a:p>
-            <a:pPr lvl="0" indent="-342900" marL="342900">
-              <a:buAutoNum type="arabicPeriod"/>
-            </a:pPr>
-            <a:r>
-              <a:rPr b="1"/>
-              <a:t>Board of directors</a:t>
-            </a:r>
-            <a:r>
-              <a:rPr/>
-              <a:t> — a room of voices (CFO, sceptical customer, growth marketer), not one answer. You weigh them.</a:t>
-            </a:r>
-          </a:p>
-          <a:p>
-            <a:pPr lvl="0" indent="-342900" marL="342900">
-              <a:buAutoNum type="arabicPeriod"/>
-            </a:pPr>
-            <a:r>
-              <a:rPr b="1"/>
-              <a:t>VET</a:t>
-            </a:r>
-            <a:r>
-              <a:rPr/>
-              <a:t> — Verify the source · Explain it back · Test the edges. For any claim you can’t check.</a:t>
-            </a:r>
-          </a:p>
-          <a:p>
-            <a:pPr lvl="0" indent="0" marL="0">
-              <a:buNone/>
-            </a:pPr>
-            <a:r>
-              <a:rPr i="1"/>
-              <a:t>Prompts for all three are on the companion site.</a:t>
+              <a:t>your</a:t>
+            </a:r>
+            <a:r>
+              <a:rPr/>
+              <a:t> voice, leading with the one thing only you would say.</a:t>
             </a:r>
           </a:p>
         </p:txBody>

</xml_diff>

<commit_message>
Slide 3: drop the editorial and the presenter note from the room-facing slide
</commit_message>
<xml_diff>
--- a/slides/deck.pptx
+++ b/slides/deck.pptx
@@ -4086,19 +4086,6 @@
             <a:r>
               <a:rPr b="1"/>
               <a:t>built in conversation with AI</a:t>
-            </a:r>
-            <a:r>
-              <a:rPr/>
-              <a:t>. That is the point.</a:t>
-            </a:r>
-          </a:p>
-          <a:p>
-            <a:pPr lvl="0" indent="0" marL="0">
-              <a:buNone/>
-            </a:pPr>
-            <a:r>
-              <a:rPr i="1"/>
-              <a:t>Thirty seconds, dry understatement, move on.</a:t>
             </a:r>
           </a:p>
         </p:txBody>

</xml_diff>

<commit_message>
Render PPTX images at print proportions
Screenshots were taken at a 1920px viewport, where the 1000px content
column and clamp()ed type float small in the frame; the PDF renders at
Chrome's 1280px print width and fills the page. Capture at 1280x720
(3x scale, still 3840x2160 output) so the PPTX matches the PDF.

Co-Authored-By: Claude Fable 5 <noreply@anthropic.com>
</commit_message>
<xml_diff>
--- a/slides/deck.pptx
+++ b/slides/deck.pptx
@@ -3134,8 +3134,8 @@
         </p:nvSpPr>
         <p:spPr>
           <a:xfrm>
-            <a:off x="2921000" y="3748881"/>
-            <a:ext cx="698500" cy="698500"/>
+            <a:off x="1333500" y="3908970"/>
+            <a:ext cx="1047750" cy="1047750"/>
           </a:xfrm>
           <a:prstGeom prst="rect">
             <a:avLst/>
@@ -3178,8 +3178,8 @@
         </p:nvSpPr>
         <p:spPr>
           <a:xfrm>
-            <a:off x="3731220" y="4171354"/>
-            <a:ext cx="2176363" cy="114300"/>
+            <a:off x="2548830" y="4542680"/>
+            <a:ext cx="3264544" cy="171450"/>
           </a:xfrm>
           <a:prstGeom prst="rect">
             <a:avLst/>
@@ -3222,8 +3222,8 @@
         </p:nvSpPr>
         <p:spPr>
           <a:xfrm>
-            <a:off x="2921000" y="4863802"/>
-            <a:ext cx="698500" cy="698500"/>
+            <a:off x="1333500" y="5581352"/>
+            <a:ext cx="1047750" cy="1047750"/>
           </a:xfrm>
           <a:prstGeom prst="rect">
             <a:avLst/>
@@ -3266,8 +3266,8 @@
         </p:nvSpPr>
         <p:spPr>
           <a:xfrm>
-            <a:off x="5337571" y="5219402"/>
-            <a:ext cx="2020887" cy="114300"/>
+            <a:off x="4958357" y="6114752"/>
+            <a:ext cx="3031331" cy="171450"/>
           </a:xfrm>
           <a:prstGeom prst="rect">
             <a:avLst/>
@@ -3478,8 +3478,8 @@
         </p:nvSpPr>
         <p:spPr>
           <a:xfrm>
-            <a:off x="2921000" y="4240113"/>
-            <a:ext cx="698500" cy="698500"/>
+            <a:off x="1333500" y="4645669"/>
+            <a:ext cx="1047750" cy="1047750"/>
           </a:xfrm>
           <a:prstGeom prst="rect">
             <a:avLst/>
@@ -3522,8 +3522,8 @@
         </p:nvSpPr>
         <p:spPr>
           <a:xfrm>
-            <a:off x="3731220" y="4595713"/>
-            <a:ext cx="2020887" cy="114300"/>
+            <a:off x="2548830" y="5179069"/>
+            <a:ext cx="3031331" cy="171450"/>
           </a:xfrm>
           <a:prstGeom prst="rect">
             <a:avLst/>
@@ -3776,8 +3776,8 @@
         </p:nvSpPr>
         <p:spPr>
           <a:xfrm>
-            <a:off x="2921000" y="4477543"/>
-            <a:ext cx="698500" cy="698500"/>
+            <a:off x="1333500" y="5001815"/>
+            <a:ext cx="1047750" cy="1047750"/>
           </a:xfrm>
           <a:prstGeom prst="rect">
             <a:avLst/>
@@ -3820,8 +3820,8 @@
         </p:nvSpPr>
         <p:spPr>
           <a:xfrm>
-            <a:off x="3731220" y="4833143"/>
-            <a:ext cx="2020887" cy="114300"/>
+            <a:off x="2548830" y="5535215"/>
+            <a:ext cx="3031331" cy="171450"/>
           </a:xfrm>
           <a:prstGeom prst="rect">
             <a:avLst/>

</xml_diff>